<commit_message>
Refactor live demo documentation and deployment instructions
- Updated live demo section in `docs/live-demo.md` to clarify deployment options for SnapDeploy and Render.
- Revised references in `submission/form-texts.md` to reflect changes in live demo hosting and accessibility.
- Modified `submission/make_deck.py` to align hosting descriptions with updated documentation.
- Adjusted content in `submission/mizan-idea-10slides.pdf` and `submission/mizan-idea-10slides.pptx` to reflect new hosting details.
- Added server error log file for better debugging.
- Introduced new views in `apps/cli/src/server/views.ts` for improved badge and verification display logic.
</commit_message>
<xml_diff>
--- a/submission/mizan-idea-10slides.pptx
+++ b/submission/mizan-idea-10slides.pptx
@@ -4027,7 +4027,7 @@
               </a:defRPr>
             </a:pPr>
             <a:r>
-              <a:t>• Hosting: Render free web service via Dockerfile + render.yaml — $0 on the free tier;</a:t>
+              <a:t>• Hosting: static exhibit on GitHub Pages; interactive demo = Dockerfile on a</a:t>
             </a:r>
           </a:p>
           <a:p>
@@ -4042,7 +4042,7 @@
               </a:defRPr>
             </a:pPr>
             <a:r>
-              <a:t>  a model API is optional and operator-funded when a key is configured</a:t>
+              <a:t>  free container host (no credit card); a model API is optional, operator-funded</a:t>
             </a:r>
           </a:p>
           <a:p>

</xml_diff>